<commit_message>
Update PowerPoint for song #5 in FUBC - Українські
</commit_message>
<xml_diff>
--- a/fubc-ua/5-Прославте всі Христа.pptx
+++ b/fubc-ua/5-Прославте всі Христа.pptx
@@ -13,15 +13,9 @@
     <p:sldId id="261" r:id="rId7"/>
     <p:sldId id="262" r:id="rId8"/>
     <p:sldId id="263" r:id="rId9"/>
-    <p:sldId id="264" r:id="rId10"/>
-    <p:sldId id="265" r:id="rId11"/>
-    <p:sldId id="266" r:id="rId12"/>
-    <p:sldId id="267" r:id="rId13"/>
-    <p:sldId id="268" r:id="rId14"/>
-    <p:sldId id="269" r:id="rId15"/>
   </p:sldIdLst>
   <p:notesMasterIdLst>
-    <p:notesMasterId r:id="rId16"/>
+    <p:notesMasterId r:id="rId10"/>
   </p:notesMasterIdLst>
   <p:sldSz cx="12192000" cy="6858000"/>
   <p:notesSz cx="6858000" cy="12192000"/>
@@ -557,446 +551,6 @@
 </p:notes>
 </file>
 
-<file path=ppt/notesSlides/notesSlide10.xml><?xml version="1.0" encoding="utf-8"?>
-<p:notes xmlns:a="http://schemas.openxmlformats.org/drawingml/2006/main" xmlns:r="http://schemas.openxmlformats.org/officeDocument/2006/relationships" xmlns:p="http://schemas.openxmlformats.org/presentationml/2006/main">
-  <p:cSld>
-    <p:spTree>
-      <p:nvGrpSpPr>
-        <p:cNvPr id="1" name=""/>
-        <p:cNvGrpSpPr/>
-        <p:nvPr/>
-      </p:nvGrpSpPr>
-      <p:grpSpPr>
-        <a:xfrm>
-          <a:off x="0" y="0"/>
-          <a:ext cx="0" cy="0"/>
-          <a:chOff x="0" y="0"/>
-          <a:chExt cx="0" cy="0"/>
-        </a:xfrm>
-      </p:grpSpPr>
-      <p:sp>
-        <p:nvSpPr>
-          <p:cNvPr id="2" name="Slide Image Placeholder 1"/>
-          <p:cNvSpPr>
-            <a:spLocks noGrp="1" noRot="1" noChangeAspect="1"/>
-          </p:cNvSpPr>
-          <p:nvPr>
-            <p:ph type="sldImg"/>
-          </p:nvPr>
-        </p:nvSpPr>
-        <p:spPr/>
-      </p:sp>
-      <p:sp>
-        <p:nvSpPr>
-          <p:cNvPr id="3" name="Notes Placeholder 2"/>
-          <p:cNvSpPr>
-            <a:spLocks noGrp="1"/>
-          </p:cNvSpPr>
-          <p:nvPr>
-            <p:ph type="body" idx="1"/>
-          </p:nvPr>
-        </p:nvSpPr>
-        <p:spPr/>
-        <p:txBody>
-          <a:bodyPr/>
-          <a:lstStyle/>
-          <a:p>
-            <a:r>
-              <a:rPr lang="en-US" dirty="0"/>
-              <a:t/>
-            </a:r>
-            <a:endParaRPr lang="en-US" dirty="0"/>
-          </a:p>
-        </p:txBody>
-      </p:sp>
-      <p:sp>
-        <p:nvSpPr>
-          <p:cNvPr id="4" name="Slide Number Placeholder 3"/>
-          <p:cNvSpPr>
-            <a:spLocks noGrp="1"/>
-          </p:cNvSpPr>
-          <p:nvPr>
-            <p:ph type="sldNum" sz="quarter" idx="10"/>
-          </p:nvPr>
-        </p:nvSpPr>
-        <p:spPr/>
-        <p:txBody>
-          <a:bodyPr/>
-          <a:lstStyle/>
-          <a:p>
-            <a:fld id="{F7021451-1387-4CA6-816F-3879F97B5CBC}" type="slidenum">
-              <a:rPr lang="en-US"/>
-              <a:t>10</a:t>
-            </a:fld>
-            <a:endParaRPr lang="en-US"/>
-          </a:p>
-        </p:txBody>
-      </p:sp>
-    </p:spTree>
-    <p:extLst>
-      <p:ext uri="{BB962C8B-B14F-4D97-AF65-F5344CB8AC3E}">
-        <p14:creationId xmlns:p14="http://schemas.microsoft.com/office/powerpoint/2010/main" val="1024086991"/>
-      </p:ext>
-    </p:extLst>
-  </p:cSld>
-  <p:clrMapOvr>
-    <a:masterClrMapping/>
-  </p:clrMapOvr>
-</p:notes>
-</file>
-
-<file path=ppt/notesSlides/notesSlide11.xml><?xml version="1.0" encoding="utf-8"?>
-<p:notes xmlns:a="http://schemas.openxmlformats.org/drawingml/2006/main" xmlns:r="http://schemas.openxmlformats.org/officeDocument/2006/relationships" xmlns:p="http://schemas.openxmlformats.org/presentationml/2006/main">
-  <p:cSld>
-    <p:spTree>
-      <p:nvGrpSpPr>
-        <p:cNvPr id="1" name=""/>
-        <p:cNvGrpSpPr/>
-        <p:nvPr/>
-      </p:nvGrpSpPr>
-      <p:grpSpPr>
-        <a:xfrm>
-          <a:off x="0" y="0"/>
-          <a:ext cx="0" cy="0"/>
-          <a:chOff x="0" y="0"/>
-          <a:chExt cx="0" cy="0"/>
-        </a:xfrm>
-      </p:grpSpPr>
-      <p:sp>
-        <p:nvSpPr>
-          <p:cNvPr id="2" name="Slide Image Placeholder 1"/>
-          <p:cNvSpPr>
-            <a:spLocks noGrp="1" noRot="1" noChangeAspect="1"/>
-          </p:cNvSpPr>
-          <p:nvPr>
-            <p:ph type="sldImg"/>
-          </p:nvPr>
-        </p:nvSpPr>
-        <p:spPr/>
-      </p:sp>
-      <p:sp>
-        <p:nvSpPr>
-          <p:cNvPr id="3" name="Notes Placeholder 2"/>
-          <p:cNvSpPr>
-            <a:spLocks noGrp="1"/>
-          </p:cNvSpPr>
-          <p:nvPr>
-            <p:ph type="body" idx="1"/>
-          </p:nvPr>
-        </p:nvSpPr>
-        <p:spPr/>
-        <p:txBody>
-          <a:bodyPr/>
-          <a:lstStyle/>
-          <a:p>
-            <a:r>
-              <a:rPr lang="en-US" dirty="0"/>
-              <a:t/>
-            </a:r>
-            <a:endParaRPr lang="en-US" dirty="0"/>
-          </a:p>
-        </p:txBody>
-      </p:sp>
-      <p:sp>
-        <p:nvSpPr>
-          <p:cNvPr id="4" name="Slide Number Placeholder 3"/>
-          <p:cNvSpPr>
-            <a:spLocks noGrp="1"/>
-          </p:cNvSpPr>
-          <p:nvPr>
-            <p:ph type="sldNum" sz="quarter" idx="10"/>
-          </p:nvPr>
-        </p:nvSpPr>
-        <p:spPr/>
-        <p:txBody>
-          <a:bodyPr/>
-          <a:lstStyle/>
-          <a:p>
-            <a:fld id="{F7021451-1387-4CA6-816F-3879F97B5CBC}" type="slidenum">
-              <a:rPr lang="en-US"/>
-              <a:t>11</a:t>
-            </a:fld>
-            <a:endParaRPr lang="en-US"/>
-          </a:p>
-        </p:txBody>
-      </p:sp>
-    </p:spTree>
-    <p:extLst>
-      <p:ext uri="{BB962C8B-B14F-4D97-AF65-F5344CB8AC3E}">
-        <p14:creationId xmlns:p14="http://schemas.microsoft.com/office/powerpoint/2010/main" val="1024086991"/>
-      </p:ext>
-    </p:extLst>
-  </p:cSld>
-  <p:clrMapOvr>
-    <a:masterClrMapping/>
-  </p:clrMapOvr>
-</p:notes>
-</file>
-
-<file path=ppt/notesSlides/notesSlide12.xml><?xml version="1.0" encoding="utf-8"?>
-<p:notes xmlns:a="http://schemas.openxmlformats.org/drawingml/2006/main" xmlns:r="http://schemas.openxmlformats.org/officeDocument/2006/relationships" xmlns:p="http://schemas.openxmlformats.org/presentationml/2006/main">
-  <p:cSld>
-    <p:spTree>
-      <p:nvGrpSpPr>
-        <p:cNvPr id="1" name=""/>
-        <p:cNvGrpSpPr/>
-        <p:nvPr/>
-      </p:nvGrpSpPr>
-      <p:grpSpPr>
-        <a:xfrm>
-          <a:off x="0" y="0"/>
-          <a:ext cx="0" cy="0"/>
-          <a:chOff x="0" y="0"/>
-          <a:chExt cx="0" cy="0"/>
-        </a:xfrm>
-      </p:grpSpPr>
-      <p:sp>
-        <p:nvSpPr>
-          <p:cNvPr id="2" name="Slide Image Placeholder 1"/>
-          <p:cNvSpPr>
-            <a:spLocks noGrp="1" noRot="1" noChangeAspect="1"/>
-          </p:cNvSpPr>
-          <p:nvPr>
-            <p:ph type="sldImg"/>
-          </p:nvPr>
-        </p:nvSpPr>
-        <p:spPr/>
-      </p:sp>
-      <p:sp>
-        <p:nvSpPr>
-          <p:cNvPr id="3" name="Notes Placeholder 2"/>
-          <p:cNvSpPr>
-            <a:spLocks noGrp="1"/>
-          </p:cNvSpPr>
-          <p:nvPr>
-            <p:ph type="body" idx="1"/>
-          </p:nvPr>
-        </p:nvSpPr>
-        <p:spPr/>
-        <p:txBody>
-          <a:bodyPr/>
-          <a:lstStyle/>
-          <a:p>
-            <a:r>
-              <a:rPr lang="en-US" dirty="0"/>
-              <a:t/>
-            </a:r>
-            <a:endParaRPr lang="en-US" dirty="0"/>
-          </a:p>
-        </p:txBody>
-      </p:sp>
-      <p:sp>
-        <p:nvSpPr>
-          <p:cNvPr id="4" name="Slide Number Placeholder 3"/>
-          <p:cNvSpPr>
-            <a:spLocks noGrp="1"/>
-          </p:cNvSpPr>
-          <p:nvPr>
-            <p:ph type="sldNum" sz="quarter" idx="10"/>
-          </p:nvPr>
-        </p:nvSpPr>
-        <p:spPr/>
-        <p:txBody>
-          <a:bodyPr/>
-          <a:lstStyle/>
-          <a:p>
-            <a:fld id="{F7021451-1387-4CA6-816F-3879F97B5CBC}" type="slidenum">
-              <a:rPr lang="en-US"/>
-              <a:t>12</a:t>
-            </a:fld>
-            <a:endParaRPr lang="en-US"/>
-          </a:p>
-        </p:txBody>
-      </p:sp>
-    </p:spTree>
-    <p:extLst>
-      <p:ext uri="{BB962C8B-B14F-4D97-AF65-F5344CB8AC3E}">
-        <p14:creationId xmlns:p14="http://schemas.microsoft.com/office/powerpoint/2010/main" val="1024086991"/>
-      </p:ext>
-    </p:extLst>
-  </p:cSld>
-  <p:clrMapOvr>
-    <a:masterClrMapping/>
-  </p:clrMapOvr>
-</p:notes>
-</file>
-
-<file path=ppt/notesSlides/notesSlide13.xml><?xml version="1.0" encoding="utf-8"?>
-<p:notes xmlns:a="http://schemas.openxmlformats.org/drawingml/2006/main" xmlns:r="http://schemas.openxmlformats.org/officeDocument/2006/relationships" xmlns:p="http://schemas.openxmlformats.org/presentationml/2006/main">
-  <p:cSld>
-    <p:spTree>
-      <p:nvGrpSpPr>
-        <p:cNvPr id="1" name=""/>
-        <p:cNvGrpSpPr/>
-        <p:nvPr/>
-      </p:nvGrpSpPr>
-      <p:grpSpPr>
-        <a:xfrm>
-          <a:off x="0" y="0"/>
-          <a:ext cx="0" cy="0"/>
-          <a:chOff x="0" y="0"/>
-          <a:chExt cx="0" cy="0"/>
-        </a:xfrm>
-      </p:grpSpPr>
-      <p:sp>
-        <p:nvSpPr>
-          <p:cNvPr id="2" name="Slide Image Placeholder 1"/>
-          <p:cNvSpPr>
-            <a:spLocks noGrp="1" noRot="1" noChangeAspect="1"/>
-          </p:cNvSpPr>
-          <p:nvPr>
-            <p:ph type="sldImg"/>
-          </p:nvPr>
-        </p:nvSpPr>
-        <p:spPr/>
-      </p:sp>
-      <p:sp>
-        <p:nvSpPr>
-          <p:cNvPr id="3" name="Notes Placeholder 2"/>
-          <p:cNvSpPr>
-            <a:spLocks noGrp="1"/>
-          </p:cNvSpPr>
-          <p:nvPr>
-            <p:ph type="body" idx="1"/>
-          </p:nvPr>
-        </p:nvSpPr>
-        <p:spPr/>
-        <p:txBody>
-          <a:bodyPr/>
-          <a:lstStyle/>
-          <a:p>
-            <a:r>
-              <a:rPr lang="en-US" dirty="0"/>
-              <a:t/>
-            </a:r>
-            <a:endParaRPr lang="en-US" dirty="0"/>
-          </a:p>
-        </p:txBody>
-      </p:sp>
-      <p:sp>
-        <p:nvSpPr>
-          <p:cNvPr id="4" name="Slide Number Placeholder 3"/>
-          <p:cNvSpPr>
-            <a:spLocks noGrp="1"/>
-          </p:cNvSpPr>
-          <p:nvPr>
-            <p:ph type="sldNum" sz="quarter" idx="10"/>
-          </p:nvPr>
-        </p:nvSpPr>
-        <p:spPr/>
-        <p:txBody>
-          <a:bodyPr/>
-          <a:lstStyle/>
-          <a:p>
-            <a:fld id="{F7021451-1387-4CA6-816F-3879F97B5CBC}" type="slidenum">
-              <a:rPr lang="en-US"/>
-              <a:t>13</a:t>
-            </a:fld>
-            <a:endParaRPr lang="en-US"/>
-          </a:p>
-        </p:txBody>
-      </p:sp>
-    </p:spTree>
-    <p:extLst>
-      <p:ext uri="{BB962C8B-B14F-4D97-AF65-F5344CB8AC3E}">
-        <p14:creationId xmlns:p14="http://schemas.microsoft.com/office/powerpoint/2010/main" val="1024086991"/>
-      </p:ext>
-    </p:extLst>
-  </p:cSld>
-  <p:clrMapOvr>
-    <a:masterClrMapping/>
-  </p:clrMapOvr>
-</p:notes>
-</file>
-
-<file path=ppt/notesSlides/notesSlide14.xml><?xml version="1.0" encoding="utf-8"?>
-<p:notes xmlns:a="http://schemas.openxmlformats.org/drawingml/2006/main" xmlns:r="http://schemas.openxmlformats.org/officeDocument/2006/relationships" xmlns:p="http://schemas.openxmlformats.org/presentationml/2006/main">
-  <p:cSld>
-    <p:spTree>
-      <p:nvGrpSpPr>
-        <p:cNvPr id="1" name=""/>
-        <p:cNvGrpSpPr/>
-        <p:nvPr/>
-      </p:nvGrpSpPr>
-      <p:grpSpPr>
-        <a:xfrm>
-          <a:off x="0" y="0"/>
-          <a:ext cx="0" cy="0"/>
-          <a:chOff x="0" y="0"/>
-          <a:chExt cx="0" cy="0"/>
-        </a:xfrm>
-      </p:grpSpPr>
-      <p:sp>
-        <p:nvSpPr>
-          <p:cNvPr id="2" name="Slide Image Placeholder 1"/>
-          <p:cNvSpPr>
-            <a:spLocks noGrp="1" noRot="1" noChangeAspect="1"/>
-          </p:cNvSpPr>
-          <p:nvPr>
-            <p:ph type="sldImg"/>
-          </p:nvPr>
-        </p:nvSpPr>
-        <p:spPr/>
-      </p:sp>
-      <p:sp>
-        <p:nvSpPr>
-          <p:cNvPr id="3" name="Notes Placeholder 2"/>
-          <p:cNvSpPr>
-            <a:spLocks noGrp="1"/>
-          </p:cNvSpPr>
-          <p:nvPr>
-            <p:ph type="body" idx="1"/>
-          </p:nvPr>
-        </p:nvSpPr>
-        <p:spPr/>
-        <p:txBody>
-          <a:bodyPr/>
-          <a:lstStyle/>
-          <a:p>
-            <a:r>
-              <a:rPr lang="en-US" dirty="0"/>
-              <a:t/>
-            </a:r>
-            <a:endParaRPr lang="en-US" dirty="0"/>
-          </a:p>
-        </p:txBody>
-      </p:sp>
-      <p:sp>
-        <p:nvSpPr>
-          <p:cNvPr id="4" name="Slide Number Placeholder 3"/>
-          <p:cNvSpPr>
-            <a:spLocks noGrp="1"/>
-          </p:cNvSpPr>
-          <p:nvPr>
-            <p:ph type="sldNum" sz="quarter" idx="10"/>
-          </p:nvPr>
-        </p:nvSpPr>
-        <p:spPr/>
-        <p:txBody>
-          <a:bodyPr/>
-          <a:lstStyle/>
-          <a:p>
-            <a:fld id="{F7021451-1387-4CA6-816F-3879F97B5CBC}" type="slidenum">
-              <a:rPr lang="en-US"/>
-              <a:t>14</a:t>
-            </a:fld>
-            <a:endParaRPr lang="en-US"/>
-          </a:p>
-        </p:txBody>
-      </p:sp>
-    </p:spTree>
-    <p:extLst>
-      <p:ext uri="{BB962C8B-B14F-4D97-AF65-F5344CB8AC3E}">
-        <p14:creationId xmlns:p14="http://schemas.microsoft.com/office/powerpoint/2010/main" val="1024086991"/>
-      </p:ext>
-    </p:extLst>
-  </p:cSld>
-  <p:clrMapOvr>
-    <a:masterClrMapping/>
-  </p:clrMapOvr>
-</p:notes>
-</file>
-
 <file path=ppt/notesSlides/notesSlide2.xml><?xml version="1.0" encoding="utf-8"?>
 <p:notes xmlns:a="http://schemas.openxmlformats.org/drawingml/2006/main" xmlns:r="http://schemas.openxmlformats.org/officeDocument/2006/relationships" xmlns:p="http://schemas.openxmlformats.org/presentationml/2006/main">
   <p:cSld>
@@ -1595,94 +1149,6 @@
             <a:fld id="{F7021451-1387-4CA6-816F-3879F97B5CBC}" type="slidenum">
               <a:rPr lang="en-US"/>
               <a:t>8</a:t>
-            </a:fld>
-            <a:endParaRPr lang="en-US"/>
-          </a:p>
-        </p:txBody>
-      </p:sp>
-    </p:spTree>
-    <p:extLst>
-      <p:ext uri="{BB962C8B-B14F-4D97-AF65-F5344CB8AC3E}">
-        <p14:creationId xmlns:p14="http://schemas.microsoft.com/office/powerpoint/2010/main" val="1024086991"/>
-      </p:ext>
-    </p:extLst>
-  </p:cSld>
-  <p:clrMapOvr>
-    <a:masterClrMapping/>
-  </p:clrMapOvr>
-</p:notes>
-</file>
-
-<file path=ppt/notesSlides/notesSlide9.xml><?xml version="1.0" encoding="utf-8"?>
-<p:notes xmlns:a="http://schemas.openxmlformats.org/drawingml/2006/main" xmlns:r="http://schemas.openxmlformats.org/officeDocument/2006/relationships" xmlns:p="http://schemas.openxmlformats.org/presentationml/2006/main">
-  <p:cSld>
-    <p:spTree>
-      <p:nvGrpSpPr>
-        <p:cNvPr id="1" name=""/>
-        <p:cNvGrpSpPr/>
-        <p:nvPr/>
-      </p:nvGrpSpPr>
-      <p:grpSpPr>
-        <a:xfrm>
-          <a:off x="0" y="0"/>
-          <a:ext cx="0" cy="0"/>
-          <a:chOff x="0" y="0"/>
-          <a:chExt cx="0" cy="0"/>
-        </a:xfrm>
-      </p:grpSpPr>
-      <p:sp>
-        <p:nvSpPr>
-          <p:cNvPr id="2" name="Slide Image Placeholder 1"/>
-          <p:cNvSpPr>
-            <a:spLocks noGrp="1" noRot="1" noChangeAspect="1"/>
-          </p:cNvSpPr>
-          <p:nvPr>
-            <p:ph type="sldImg"/>
-          </p:nvPr>
-        </p:nvSpPr>
-        <p:spPr/>
-      </p:sp>
-      <p:sp>
-        <p:nvSpPr>
-          <p:cNvPr id="3" name="Notes Placeholder 2"/>
-          <p:cNvSpPr>
-            <a:spLocks noGrp="1"/>
-          </p:cNvSpPr>
-          <p:nvPr>
-            <p:ph type="body" idx="1"/>
-          </p:nvPr>
-        </p:nvSpPr>
-        <p:spPr/>
-        <p:txBody>
-          <a:bodyPr/>
-          <a:lstStyle/>
-          <a:p>
-            <a:r>
-              <a:rPr lang="en-US" dirty="0"/>
-              <a:t/>
-            </a:r>
-            <a:endParaRPr lang="en-US" dirty="0"/>
-          </a:p>
-        </p:txBody>
-      </p:sp>
-      <p:sp>
-        <p:nvSpPr>
-          <p:cNvPr id="4" name="Slide Number Placeholder 3"/>
-          <p:cNvSpPr>
-            <a:spLocks noGrp="1"/>
-          </p:cNvSpPr>
-          <p:nvPr>
-            <p:ph type="sldNum" sz="quarter" idx="10"/>
-          </p:nvPr>
-        </p:nvSpPr>
-        <p:spPr/>
-        <p:txBody>
-          <a:bodyPr/>
-          <a:lstStyle/>
-          <a:p>
-            <a:fld id="{F7021451-1387-4CA6-816F-3879F97B5CBC}" type="slidenum">
-              <a:rPr lang="en-US"/>
-              <a:t>9</a:t>
             </a:fld>
             <a:endParaRPr lang="en-US"/>
           </a:p>
@@ -2079,9 +1545,9 @@
 </p:sld>
 </file>
 
-<file path=ppt/slides/slide10.xml><?xml version="1.0" encoding="utf-8"?>
+<file path=ppt/slides/slide2.xml><?xml version="1.0" encoding="utf-8"?>
 <p:sld xmlns:a="http://schemas.openxmlformats.org/drawingml/2006/main" xmlns:r="http://schemas.openxmlformats.org/officeDocument/2006/relationships" xmlns:p="http://schemas.openxmlformats.org/presentationml/2006/main">
-  <p:cSld name="Slide 10">
+  <p:cSld name="Slide 2">
     <p:bg>
       <p:bgPr>
         <a:solidFill>
@@ -2136,7 +1602,7 @@
                 <a:ea typeface="Arial" pitchFamily="34" charset="-122"/>
                 <a:cs typeface="Arial" pitchFamily="34" charset="-120"/>
               </a:rPr>
-              <a:t>Славте Царя віків, </a:t>
+              <a:t>Прославте всі Христа! </a:t>
             </a:r>
             <a:endParaRPr lang="en-US" sz="4900" dirty="0"/>
           </a:p>
@@ -2153,7 +1619,7 @@
                 <a:ea typeface="Arial" pitchFamily="34" charset="-122"/>
                 <a:cs typeface="Arial" pitchFamily="34" charset="-120"/>
               </a:rPr>
-              <a:t>бо смерть Він переміг!</a:t>
+              <a:t>Зійшов Він на престол.</a:t>
             </a:r>
             <a:endParaRPr lang="en-US" sz="4900" dirty="0"/>
           </a:p>
@@ -2170,7 +1636,7 @@
                 <a:ea typeface="Arial" pitchFamily="34" charset="-122"/>
                 <a:cs typeface="Arial" pitchFamily="34" charset="-120"/>
               </a:rPr>
-              <a:t>Людей спасати від гріха </a:t>
+              <a:t>Співають Анголи в красі, </a:t>
             </a:r>
             <a:endParaRPr lang="en-US" sz="4900" dirty="0"/>
           </a:p>
@@ -2187,7 +1653,7 @@
                 <a:ea typeface="Arial" pitchFamily="34" charset="-122"/>
                 <a:cs typeface="Arial" pitchFamily="34" charset="-120"/>
               </a:rPr>
-              <a:t>і досі сильний Він.</a:t>
+              <a:t>звучить небесний хор.</a:t>
             </a:r>
             <a:endParaRPr lang="en-US" sz="4900" dirty="0"/>
           </a:p>
@@ -2201,9 +1667,9 @@
 </p:sld>
 </file>
 
-<file path=ppt/slides/slide11.xml><?xml version="1.0" encoding="utf-8"?>
+<file path=ppt/slides/slide3.xml><?xml version="1.0" encoding="utf-8"?>
 <p:sld xmlns:a="http://schemas.openxmlformats.org/drawingml/2006/main" xmlns:r="http://schemas.openxmlformats.org/officeDocument/2006/relationships" xmlns:p="http://schemas.openxmlformats.org/presentationml/2006/main">
-  <p:cSld name="Slide 11">
+  <p:cSld name="Slide 3">
     <p:bg>
       <p:bgPr>
         <a:solidFill>
@@ -2258,7 +1724,7 @@
                 <a:ea typeface="Arial" pitchFamily="34" charset="-122"/>
                 <a:cs typeface="Arial" pitchFamily="34" charset="-120"/>
               </a:rPr>
-              <a:t>Ісусу честь, хвала, </a:t>
+              <a:t>Співай душа, радій, </a:t>
             </a:r>
             <a:endParaRPr lang="en-US" sz="4900" dirty="0"/>
           </a:p>
@@ -2275,7 +1741,7 @@
                 <a:ea typeface="Arial" pitchFamily="34" charset="-122"/>
                 <a:cs typeface="Arial" pitchFamily="34" charset="-120"/>
               </a:rPr>
-              <a:t>бо Він навік живий,</a:t>
+              <a:t>Христос Спаситель твій,</a:t>
             </a:r>
             <a:endParaRPr lang="en-US" sz="4900" dirty="0"/>
           </a:p>
@@ -2292,7 +1758,7 @@
                 <a:ea typeface="Arial" pitchFamily="34" charset="-122"/>
                 <a:cs typeface="Arial" pitchFamily="34" charset="-120"/>
               </a:rPr>
-              <a:t>Він нас простив, звільнив від зла, </a:t>
+              <a:t>Він Відкупитель всеблагий, </a:t>
             </a:r>
             <a:endParaRPr lang="en-US" sz="4900" dirty="0"/>
           </a:p>
@@ -2309,7 +1775,7 @@
                 <a:ea typeface="Arial" pitchFamily="34" charset="-122"/>
                 <a:cs typeface="Arial" pitchFamily="34" charset="-120"/>
               </a:rPr>
-              <a:t>й веде у вічний дім!</a:t>
+              <a:t>Він Цар твій назавжди.</a:t>
             </a:r>
             <a:endParaRPr lang="en-US" sz="4900" dirty="0"/>
           </a:p>
@@ -2323,9 +1789,9 @@
 </p:sld>
 </file>
 
-<file path=ppt/slides/slide12.xml><?xml version="1.0" encoding="utf-8"?>
+<file path=ppt/slides/slide4.xml><?xml version="1.0" encoding="utf-8"?>
 <p:sld xmlns:a="http://schemas.openxmlformats.org/drawingml/2006/main" xmlns:r="http://schemas.openxmlformats.org/officeDocument/2006/relationships" xmlns:p="http://schemas.openxmlformats.org/presentationml/2006/main">
-  <p:cSld name="Slide 12">
+  <p:cSld name="Slide 4">
     <p:bg>
       <p:bgPr>
         <a:solidFill>
@@ -2380,7 +1846,7 @@
                 <a:ea typeface="Arial" pitchFamily="34" charset="-122"/>
                 <a:cs typeface="Arial" pitchFamily="34" charset="-120"/>
               </a:rPr>
-              <a:t>Славте Царя небес, </a:t>
+              <a:t>Славте Царя віків, </a:t>
             </a:r>
             <a:endParaRPr lang="en-US" sz="4900" dirty="0"/>
           </a:p>
@@ -2397,7 +1863,7 @@
                 <a:ea typeface="Arial" pitchFamily="34" charset="-122"/>
                 <a:cs typeface="Arial" pitchFamily="34" charset="-120"/>
               </a:rPr>
-              <a:t>єдиного з Отцем!</a:t>
+              <a:t>бо смерть Він переміг!</a:t>
             </a:r>
             <a:endParaRPr lang="en-US" sz="4900" dirty="0"/>
           </a:p>
@@ -2414,7 +1880,7 @@
                 <a:ea typeface="Arial" pitchFamily="34" charset="-122"/>
                 <a:cs typeface="Arial" pitchFamily="34" charset="-120"/>
               </a:rPr>
-              <a:t>Святого Духа що в серцях </a:t>
+              <a:t>Людей спасати від гріха </a:t>
             </a:r>
             <a:endParaRPr lang="en-US" sz="4900" dirty="0"/>
           </a:p>
@@ -2431,7 +1897,7 @@
                 <a:ea typeface="Arial" pitchFamily="34" charset="-122"/>
                 <a:cs typeface="Arial" pitchFamily="34" charset="-120"/>
               </a:rPr>
-              <a:t>відкуплених живе!</a:t>
+              <a:t>і досі сильний Він.</a:t>
             </a:r>
             <a:endParaRPr lang="en-US" sz="4900" dirty="0"/>
           </a:p>
@@ -2445,9 +1911,9 @@
 </p:sld>
 </file>
 
-<file path=ppt/slides/slide13.xml><?xml version="1.0" encoding="utf-8"?>
+<file path=ppt/slides/slide5.xml><?xml version="1.0" encoding="utf-8"?>
 <p:sld xmlns:a="http://schemas.openxmlformats.org/drawingml/2006/main" xmlns:r="http://schemas.openxmlformats.org/officeDocument/2006/relationships" xmlns:p="http://schemas.openxmlformats.org/presentationml/2006/main">
-  <p:cSld name="Slide 13">
+  <p:cSld name="Slide 5">
     <p:bg>
       <p:bgPr>
         <a:solidFill>
@@ -2502,7 +1968,7 @@
                 <a:ea typeface="Arial" pitchFamily="34" charset="-122"/>
                 <a:cs typeface="Arial" pitchFamily="34" charset="-120"/>
               </a:rPr>
-              <a:t>Народи племена </a:t>
+              <a:t>Ісусу честь, хвала, </a:t>
             </a:r>
             <a:endParaRPr lang="en-US" sz="4900" dirty="0"/>
           </a:p>
@@ -2519,7 +1985,7 @@
                 <a:ea typeface="Arial" pitchFamily="34" charset="-122"/>
                 <a:cs typeface="Arial" pitchFamily="34" charset="-120"/>
               </a:rPr>
-              <a:t>звеличуйте Царя.</a:t>
+              <a:t>бо Він навік живий,</a:t>
             </a:r>
             <a:endParaRPr lang="en-US" sz="4900" dirty="0"/>
           </a:p>
@@ -2536,7 +2002,7 @@
                 <a:ea typeface="Arial" pitchFamily="34" charset="-122"/>
                 <a:cs typeface="Arial" pitchFamily="34" charset="-120"/>
               </a:rPr>
-              <a:t>Пошану й честь Йому складіть </a:t>
+              <a:t>Він нас простив, звільнив від зла, </a:t>
             </a:r>
             <a:endParaRPr lang="en-US" sz="4900" dirty="0"/>
           </a:p>
@@ -2553,30 +2019,7 @@
                 <a:ea typeface="Arial" pitchFamily="34" charset="-122"/>
                 <a:cs typeface="Arial" pitchFamily="34" charset="-120"/>
               </a:rPr>
-              <a:t>за всі Його діла.</a:t>
-            </a:r>
-            <a:endParaRPr lang="en-US" sz="4900" dirty="0"/>
-          </a:p>
-          <a:p>
-            <a:pPr algn="ctr" indent="0" marL="0">
-              <a:buNone/>
-            </a:pPr>
-            <a:endParaRPr lang="en-US" sz="4900" dirty="0"/>
-          </a:p>
-          <a:p>
-            <a:pPr algn="ctr" indent="0" marL="0">
-              <a:buNone/>
-            </a:pPr>
-            <a:r>
-              <a:rPr lang="en-US" sz="4900" b="1" dirty="0">
-                <a:solidFill>
-                  <a:srgbClr val="FFFFFF"/>
-                </a:solidFill>
-                <a:latin typeface="Arial" pitchFamily="34" charset="0"/>
-                <a:ea typeface="Arial" pitchFamily="34" charset="-122"/>
-                <a:cs typeface="Arial" pitchFamily="34" charset="-120"/>
-              </a:rPr>
-              <a:t>***</a:t>
+              <a:t>й веде у вічний дім!</a:t>
             </a:r>
             <a:endParaRPr lang="en-US" sz="4900" dirty="0"/>
           </a:p>
@@ -2590,9 +2033,9 @@
 </p:sld>
 </file>
 
-<file path=ppt/slides/slide14.xml><?xml version="1.0" encoding="utf-8"?>
+<file path=ppt/slides/slide6.xml><?xml version="1.0" encoding="utf-8"?>
 <p:sld xmlns:a="http://schemas.openxmlformats.org/drawingml/2006/main" xmlns:r="http://schemas.openxmlformats.org/officeDocument/2006/relationships" xmlns:p="http://schemas.openxmlformats.org/presentationml/2006/main">
-  <p:cSld name="Slide 14">
+  <p:cSld name="Slide 6">
     <p:bg>
       <p:bgPr>
         <a:solidFill>
@@ -2614,6 +2057,96 @@
           <a:chExt cx="0" cy="0"/>
         </a:xfrm>
       </p:grpSpPr>
+      <p:sp>
+        <p:nvSpPr>
+          <p:cNvPr id="2" name="Text 0"/>
+          <p:cNvSpPr txBox="1"/>
+          <p:nvPr/>
+        </p:nvSpPr>
+        <p:spPr>
+          <a:xfrm>
+            <a:off x="548640" y="457200"/>
+            <a:ext cx="11064240" cy="5943600"/>
+          </a:xfrm>
+          <a:prstGeom prst="rect">
+            <a:avLst/>
+          </a:prstGeom>
+          <a:noFill/>
+          <a:ln/>
+        </p:spPr>
+        <p:txBody>
+          <a:bodyPr wrap="square" lIns="0" tIns="0" rIns="0" bIns="0" rtlCol="0" anchor="ctr"/>
+          <a:lstStyle/>
+          <a:p>
+            <a:pPr algn="ctr" indent="0" marL="0">
+              <a:buNone/>
+            </a:pPr>
+            <a:r>
+              <a:rPr lang="en-US" sz="4900" b="1" dirty="0">
+                <a:solidFill>
+                  <a:srgbClr val="FFFFFF"/>
+                </a:solidFill>
+                <a:latin typeface="Arial" pitchFamily="34" charset="0"/>
+                <a:ea typeface="Arial" pitchFamily="34" charset="-122"/>
+                <a:cs typeface="Arial" pitchFamily="34" charset="-120"/>
+              </a:rPr>
+              <a:t>Славте Царя небес, </a:t>
+            </a:r>
+            <a:endParaRPr lang="en-US" sz="4900" dirty="0"/>
+          </a:p>
+          <a:p>
+            <a:pPr algn="ctr" indent="0" marL="0">
+              <a:buNone/>
+            </a:pPr>
+            <a:r>
+              <a:rPr lang="en-US" sz="4900" b="1" dirty="0">
+                <a:solidFill>
+                  <a:srgbClr val="FFFFFF"/>
+                </a:solidFill>
+                <a:latin typeface="Arial" pitchFamily="34" charset="0"/>
+                <a:ea typeface="Arial" pitchFamily="34" charset="-122"/>
+                <a:cs typeface="Arial" pitchFamily="34" charset="-120"/>
+              </a:rPr>
+              <a:t>єдиного з Отцем!</a:t>
+            </a:r>
+            <a:endParaRPr lang="en-US" sz="4900" dirty="0"/>
+          </a:p>
+          <a:p>
+            <a:pPr algn="ctr" indent="0" marL="0">
+              <a:buNone/>
+            </a:pPr>
+            <a:r>
+              <a:rPr lang="en-US" sz="4900" b="1" dirty="0">
+                <a:solidFill>
+                  <a:srgbClr val="FFFFFF"/>
+                </a:solidFill>
+                <a:latin typeface="Arial" pitchFamily="34" charset="0"/>
+                <a:ea typeface="Arial" pitchFamily="34" charset="-122"/>
+                <a:cs typeface="Arial" pitchFamily="34" charset="-120"/>
+              </a:rPr>
+              <a:t>Святого Духа що в серцях </a:t>
+            </a:r>
+            <a:endParaRPr lang="en-US" sz="4900" dirty="0"/>
+          </a:p>
+          <a:p>
+            <a:pPr algn="ctr" indent="0" marL="0">
+              <a:buNone/>
+            </a:pPr>
+            <a:r>
+              <a:rPr lang="en-US" sz="4900" b="1" dirty="0">
+                <a:solidFill>
+                  <a:srgbClr val="FFFFFF"/>
+                </a:solidFill>
+                <a:latin typeface="Arial" pitchFamily="34" charset="0"/>
+                <a:ea typeface="Arial" pitchFamily="34" charset="-122"/>
+                <a:cs typeface="Arial" pitchFamily="34" charset="-120"/>
+              </a:rPr>
+              <a:t>відкуплених живе!</a:t>
+            </a:r>
+            <a:endParaRPr lang="en-US" sz="4900" dirty="0"/>
+          </a:p>
+        </p:txBody>
+      </p:sp>
     </p:spTree>
   </p:cSld>
   <p:clrMapOvr>
@@ -2622,9 +2155,9 @@
 </p:sld>
 </file>
 
-<file path=ppt/slides/slide2.xml><?xml version="1.0" encoding="utf-8"?>
+<file path=ppt/slides/slide7.xml><?xml version="1.0" encoding="utf-8"?>
 <p:sld xmlns:a="http://schemas.openxmlformats.org/drawingml/2006/main" xmlns:r="http://schemas.openxmlformats.org/officeDocument/2006/relationships" xmlns:p="http://schemas.openxmlformats.org/presentationml/2006/main">
-  <p:cSld name="Slide 2">
+  <p:cSld name="Slide 7">
     <p:bg>
       <p:bgPr>
         <a:solidFill>
@@ -2679,7 +2212,7 @@
                 <a:ea typeface="Arial" pitchFamily="34" charset="-122"/>
                 <a:cs typeface="Arial" pitchFamily="34" charset="-120"/>
               </a:rPr>
-              <a:t>Прославте всі Христа! </a:t>
+              <a:t>Народи племена </a:t>
             </a:r>
             <a:endParaRPr lang="en-US" sz="4900" dirty="0"/>
           </a:p>
@@ -2696,7 +2229,7 @@
                 <a:ea typeface="Arial" pitchFamily="34" charset="-122"/>
                 <a:cs typeface="Arial" pitchFamily="34" charset="-120"/>
               </a:rPr>
-              <a:t>Зійшов Він на престол.</a:t>
+              <a:t>звеличуйте Царя.</a:t>
             </a:r>
             <a:endParaRPr lang="en-US" sz="4900" dirty="0"/>
           </a:p>
@@ -2713,7 +2246,7 @@
                 <a:ea typeface="Arial" pitchFamily="34" charset="-122"/>
                 <a:cs typeface="Arial" pitchFamily="34" charset="-120"/>
               </a:rPr>
-              <a:t>Співають Анголи в красі, </a:t>
+              <a:t>Пошану й честь Йому </a:t>
             </a:r>
             <a:endParaRPr lang="en-US" sz="4900" dirty="0"/>
           </a:p>
@@ -2730,7 +2263,30 @@
                 <a:ea typeface="Arial" pitchFamily="34" charset="-122"/>
                 <a:cs typeface="Arial" pitchFamily="34" charset="-120"/>
               </a:rPr>
-              <a:t>звучить небесний хор.</a:t>
+              <a:t>складіть за всі Його діла.</a:t>
+            </a:r>
+            <a:endParaRPr lang="en-US" sz="4900" dirty="0"/>
+          </a:p>
+          <a:p>
+            <a:pPr algn="ctr" indent="0" marL="0">
+              <a:buNone/>
+            </a:pPr>
+            <a:endParaRPr lang="en-US" sz="4900" dirty="0"/>
+          </a:p>
+          <a:p>
+            <a:pPr algn="ctr" indent="0" marL="0">
+              <a:buNone/>
+            </a:pPr>
+            <a:r>
+              <a:rPr lang="en-US" sz="4900" b="1" dirty="0">
+                <a:solidFill>
+                  <a:srgbClr val="FFFFFF"/>
+                </a:solidFill>
+                <a:latin typeface="Arial" pitchFamily="34" charset="0"/>
+                <a:ea typeface="Arial" pitchFamily="34" charset="-122"/>
+                <a:cs typeface="Arial" pitchFamily="34" charset="-120"/>
+              </a:rPr>
+              <a:t>***</a:t>
             </a:r>
             <a:endParaRPr lang="en-US" sz="4900" dirty="0"/>
           </a:p>
@@ -2744,9 +2300,9 @@
 </p:sld>
 </file>
 
-<file path=ppt/slides/slide3.xml><?xml version="1.0" encoding="utf-8"?>
+<file path=ppt/slides/slide8.xml><?xml version="1.0" encoding="utf-8"?>
 <p:sld xmlns:a="http://schemas.openxmlformats.org/drawingml/2006/main" xmlns:r="http://schemas.openxmlformats.org/officeDocument/2006/relationships" xmlns:p="http://schemas.openxmlformats.org/presentationml/2006/main">
-  <p:cSld name="Slide 3">
+  <p:cSld name="Slide 8">
     <p:bg>
       <p:bgPr>
         <a:solidFill>
@@ -2768,828 +2324,6 @@
           <a:chExt cx="0" cy="0"/>
         </a:xfrm>
       </p:grpSpPr>
-      <p:sp>
-        <p:nvSpPr>
-          <p:cNvPr id="2" name="Text 0"/>
-          <p:cNvSpPr txBox="1"/>
-          <p:nvPr/>
-        </p:nvSpPr>
-        <p:spPr>
-          <a:xfrm>
-            <a:off x="548640" y="457200"/>
-            <a:ext cx="11064240" cy="5943600"/>
-          </a:xfrm>
-          <a:prstGeom prst="rect">
-            <a:avLst/>
-          </a:prstGeom>
-          <a:noFill/>
-          <a:ln/>
-        </p:spPr>
-        <p:txBody>
-          <a:bodyPr wrap="square" lIns="0" tIns="0" rIns="0" bIns="0" rtlCol="0" anchor="ctr"/>
-          <a:lstStyle/>
-          <a:p>
-            <a:pPr algn="ctr" indent="0" marL="0">
-              <a:buNone/>
-            </a:pPr>
-            <a:r>
-              <a:rPr lang="en-US" sz="4900" b="1" dirty="0">
-                <a:solidFill>
-                  <a:srgbClr val="FFFFFF"/>
-                </a:solidFill>
-                <a:latin typeface="Arial" pitchFamily="34" charset="0"/>
-                <a:ea typeface="Arial" pitchFamily="34" charset="-122"/>
-                <a:cs typeface="Arial" pitchFamily="34" charset="-120"/>
-              </a:rPr>
-              <a:t>Співай душа, радій, </a:t>
-            </a:r>
-            <a:endParaRPr lang="en-US" sz="4900" dirty="0"/>
-          </a:p>
-          <a:p>
-            <a:pPr algn="ctr" indent="0" marL="0">
-              <a:buNone/>
-            </a:pPr>
-            <a:r>
-              <a:rPr lang="en-US" sz="4900" b="1" dirty="0">
-                <a:solidFill>
-                  <a:srgbClr val="FFFFFF"/>
-                </a:solidFill>
-                <a:latin typeface="Arial" pitchFamily="34" charset="0"/>
-                <a:ea typeface="Arial" pitchFamily="34" charset="-122"/>
-                <a:cs typeface="Arial" pitchFamily="34" charset="-120"/>
-              </a:rPr>
-              <a:t>Христос Спаситель твій,</a:t>
-            </a:r>
-            <a:endParaRPr lang="en-US" sz="4900" dirty="0"/>
-          </a:p>
-          <a:p>
-            <a:pPr algn="ctr" indent="0" marL="0">
-              <a:buNone/>
-            </a:pPr>
-            <a:r>
-              <a:rPr lang="en-US" sz="4900" b="1" dirty="0">
-                <a:solidFill>
-                  <a:srgbClr val="FFFFFF"/>
-                </a:solidFill>
-                <a:latin typeface="Arial" pitchFamily="34" charset="0"/>
-                <a:ea typeface="Arial" pitchFamily="34" charset="-122"/>
-                <a:cs typeface="Arial" pitchFamily="34" charset="-120"/>
-              </a:rPr>
-              <a:t>Він Відкупитель всеблагий, </a:t>
-            </a:r>
-            <a:endParaRPr lang="en-US" sz="4900" dirty="0"/>
-          </a:p>
-          <a:p>
-            <a:pPr algn="ctr" indent="0" marL="0">
-              <a:buNone/>
-            </a:pPr>
-            <a:r>
-              <a:rPr lang="en-US" sz="4900" b="1" dirty="0">
-                <a:solidFill>
-                  <a:srgbClr val="FFFFFF"/>
-                </a:solidFill>
-                <a:latin typeface="Arial" pitchFamily="34" charset="0"/>
-                <a:ea typeface="Arial" pitchFamily="34" charset="-122"/>
-                <a:cs typeface="Arial" pitchFamily="34" charset="-120"/>
-              </a:rPr>
-              <a:t>Він Цар твій назавжди.</a:t>
-            </a:r>
-            <a:endParaRPr lang="en-US" sz="4900" dirty="0"/>
-          </a:p>
-        </p:txBody>
-      </p:sp>
-    </p:spTree>
-  </p:cSld>
-  <p:clrMapOvr>
-    <a:masterClrMapping/>
-  </p:clrMapOvr>
-</p:sld>
-</file>
-
-<file path=ppt/slides/slide4.xml><?xml version="1.0" encoding="utf-8"?>
-<p:sld xmlns:a="http://schemas.openxmlformats.org/drawingml/2006/main" xmlns:r="http://schemas.openxmlformats.org/officeDocument/2006/relationships" xmlns:p="http://schemas.openxmlformats.org/presentationml/2006/main">
-  <p:cSld name="Slide 4">
-    <p:bg>
-      <p:bgPr>
-        <a:solidFill>
-          <a:srgbClr val="000000"/>
-        </a:solidFill>
-      </p:bgPr>
-    </p:bg>
-    <p:spTree>
-      <p:nvGrpSpPr>
-        <p:cNvPr id="1" name=""/>
-        <p:cNvGrpSpPr/>
-        <p:nvPr/>
-      </p:nvGrpSpPr>
-      <p:grpSpPr>
-        <a:xfrm>
-          <a:off x="0" y="0"/>
-          <a:ext cx="0" cy="0"/>
-          <a:chOff x="0" y="0"/>
-          <a:chExt cx="0" cy="0"/>
-        </a:xfrm>
-      </p:grpSpPr>
-      <p:sp>
-        <p:nvSpPr>
-          <p:cNvPr id="2" name="Text 0"/>
-          <p:cNvSpPr txBox="1"/>
-          <p:nvPr/>
-        </p:nvSpPr>
-        <p:spPr>
-          <a:xfrm>
-            <a:off x="548640" y="457200"/>
-            <a:ext cx="11064240" cy="5943600"/>
-          </a:xfrm>
-          <a:prstGeom prst="rect">
-            <a:avLst/>
-          </a:prstGeom>
-          <a:noFill/>
-          <a:ln/>
-        </p:spPr>
-        <p:txBody>
-          <a:bodyPr wrap="square" lIns="0" tIns="0" rIns="0" bIns="0" rtlCol="0" anchor="ctr"/>
-          <a:lstStyle/>
-          <a:p>
-            <a:pPr algn="ctr" indent="0" marL="0">
-              <a:buNone/>
-            </a:pPr>
-            <a:r>
-              <a:rPr lang="en-US" sz="4900" b="1" dirty="0">
-                <a:solidFill>
-                  <a:srgbClr val="FFFFFF"/>
-                </a:solidFill>
-                <a:latin typeface="Arial" pitchFamily="34" charset="0"/>
-                <a:ea typeface="Arial" pitchFamily="34" charset="-122"/>
-                <a:cs typeface="Arial" pitchFamily="34" charset="-120"/>
-              </a:rPr>
-              <a:t>Славте Царя віків, </a:t>
-            </a:r>
-            <a:endParaRPr lang="en-US" sz="4900" dirty="0"/>
-          </a:p>
-          <a:p>
-            <a:pPr algn="ctr" indent="0" marL="0">
-              <a:buNone/>
-            </a:pPr>
-            <a:r>
-              <a:rPr lang="en-US" sz="4900" b="1" dirty="0">
-                <a:solidFill>
-                  <a:srgbClr val="FFFFFF"/>
-                </a:solidFill>
-                <a:latin typeface="Arial" pitchFamily="34" charset="0"/>
-                <a:ea typeface="Arial" pitchFamily="34" charset="-122"/>
-                <a:cs typeface="Arial" pitchFamily="34" charset="-120"/>
-              </a:rPr>
-              <a:t>бо смерть Він переміг!</a:t>
-            </a:r>
-            <a:endParaRPr lang="en-US" sz="4900" dirty="0"/>
-          </a:p>
-          <a:p>
-            <a:pPr algn="ctr" indent="0" marL="0">
-              <a:buNone/>
-            </a:pPr>
-            <a:r>
-              <a:rPr lang="en-US" sz="4900" b="1" dirty="0">
-                <a:solidFill>
-                  <a:srgbClr val="FFFFFF"/>
-                </a:solidFill>
-                <a:latin typeface="Arial" pitchFamily="34" charset="0"/>
-                <a:ea typeface="Arial" pitchFamily="34" charset="-122"/>
-                <a:cs typeface="Arial" pitchFamily="34" charset="-120"/>
-              </a:rPr>
-              <a:t>Людей спасати від гріха </a:t>
-            </a:r>
-            <a:endParaRPr lang="en-US" sz="4900" dirty="0"/>
-          </a:p>
-          <a:p>
-            <a:pPr algn="ctr" indent="0" marL="0">
-              <a:buNone/>
-            </a:pPr>
-            <a:r>
-              <a:rPr lang="en-US" sz="4900" b="1" dirty="0">
-                <a:solidFill>
-                  <a:srgbClr val="FFFFFF"/>
-                </a:solidFill>
-                <a:latin typeface="Arial" pitchFamily="34" charset="0"/>
-                <a:ea typeface="Arial" pitchFamily="34" charset="-122"/>
-                <a:cs typeface="Arial" pitchFamily="34" charset="-120"/>
-              </a:rPr>
-              <a:t>і досі сильний Він.</a:t>
-            </a:r>
-            <a:endParaRPr lang="en-US" sz="4900" dirty="0"/>
-          </a:p>
-        </p:txBody>
-      </p:sp>
-    </p:spTree>
-  </p:cSld>
-  <p:clrMapOvr>
-    <a:masterClrMapping/>
-  </p:clrMapOvr>
-</p:sld>
-</file>
-
-<file path=ppt/slides/slide5.xml><?xml version="1.0" encoding="utf-8"?>
-<p:sld xmlns:a="http://schemas.openxmlformats.org/drawingml/2006/main" xmlns:r="http://schemas.openxmlformats.org/officeDocument/2006/relationships" xmlns:p="http://schemas.openxmlformats.org/presentationml/2006/main">
-  <p:cSld name="Slide 5">
-    <p:bg>
-      <p:bgPr>
-        <a:solidFill>
-          <a:srgbClr val="000000"/>
-        </a:solidFill>
-      </p:bgPr>
-    </p:bg>
-    <p:spTree>
-      <p:nvGrpSpPr>
-        <p:cNvPr id="1" name=""/>
-        <p:cNvGrpSpPr/>
-        <p:nvPr/>
-      </p:nvGrpSpPr>
-      <p:grpSpPr>
-        <a:xfrm>
-          <a:off x="0" y="0"/>
-          <a:ext cx="0" cy="0"/>
-          <a:chOff x="0" y="0"/>
-          <a:chExt cx="0" cy="0"/>
-        </a:xfrm>
-      </p:grpSpPr>
-      <p:sp>
-        <p:nvSpPr>
-          <p:cNvPr id="2" name="Text 0"/>
-          <p:cNvSpPr txBox="1"/>
-          <p:nvPr/>
-        </p:nvSpPr>
-        <p:spPr>
-          <a:xfrm>
-            <a:off x="548640" y="457200"/>
-            <a:ext cx="11064240" cy="5943600"/>
-          </a:xfrm>
-          <a:prstGeom prst="rect">
-            <a:avLst/>
-          </a:prstGeom>
-          <a:noFill/>
-          <a:ln/>
-        </p:spPr>
-        <p:txBody>
-          <a:bodyPr wrap="square" lIns="0" tIns="0" rIns="0" bIns="0" rtlCol="0" anchor="ctr"/>
-          <a:lstStyle/>
-          <a:p>
-            <a:pPr algn="ctr" indent="0" marL="0">
-              <a:buNone/>
-            </a:pPr>
-            <a:r>
-              <a:rPr lang="en-US" sz="4900" b="1" dirty="0">
-                <a:solidFill>
-                  <a:srgbClr val="FFFFFF"/>
-                </a:solidFill>
-                <a:latin typeface="Arial" pitchFamily="34" charset="0"/>
-                <a:ea typeface="Arial" pitchFamily="34" charset="-122"/>
-                <a:cs typeface="Arial" pitchFamily="34" charset="-120"/>
-              </a:rPr>
-              <a:t>Ісусу честь, хвала, </a:t>
-            </a:r>
-            <a:endParaRPr lang="en-US" sz="4900" dirty="0"/>
-          </a:p>
-          <a:p>
-            <a:pPr algn="ctr" indent="0" marL="0">
-              <a:buNone/>
-            </a:pPr>
-            <a:r>
-              <a:rPr lang="en-US" sz="4900" b="1" dirty="0">
-                <a:solidFill>
-                  <a:srgbClr val="FFFFFF"/>
-                </a:solidFill>
-                <a:latin typeface="Arial" pitchFamily="34" charset="0"/>
-                <a:ea typeface="Arial" pitchFamily="34" charset="-122"/>
-                <a:cs typeface="Arial" pitchFamily="34" charset="-120"/>
-              </a:rPr>
-              <a:t>бо Він навік живий,</a:t>
-            </a:r>
-            <a:endParaRPr lang="en-US" sz="4900" dirty="0"/>
-          </a:p>
-          <a:p>
-            <a:pPr algn="ctr" indent="0" marL="0">
-              <a:buNone/>
-            </a:pPr>
-            <a:r>
-              <a:rPr lang="en-US" sz="4900" b="1" dirty="0">
-                <a:solidFill>
-                  <a:srgbClr val="FFFFFF"/>
-                </a:solidFill>
-                <a:latin typeface="Arial" pitchFamily="34" charset="0"/>
-                <a:ea typeface="Arial" pitchFamily="34" charset="-122"/>
-                <a:cs typeface="Arial" pitchFamily="34" charset="-120"/>
-              </a:rPr>
-              <a:t>Він нас простив, звільнив від зла, </a:t>
-            </a:r>
-            <a:endParaRPr lang="en-US" sz="4900" dirty="0"/>
-          </a:p>
-          <a:p>
-            <a:pPr algn="ctr" indent="0" marL="0">
-              <a:buNone/>
-            </a:pPr>
-            <a:r>
-              <a:rPr lang="en-US" sz="4900" b="1" dirty="0">
-                <a:solidFill>
-                  <a:srgbClr val="FFFFFF"/>
-                </a:solidFill>
-                <a:latin typeface="Arial" pitchFamily="34" charset="0"/>
-                <a:ea typeface="Arial" pitchFamily="34" charset="-122"/>
-                <a:cs typeface="Arial" pitchFamily="34" charset="-120"/>
-              </a:rPr>
-              <a:t>й веде у вічний дім!</a:t>
-            </a:r>
-            <a:endParaRPr lang="en-US" sz="4900" dirty="0"/>
-          </a:p>
-        </p:txBody>
-      </p:sp>
-    </p:spTree>
-  </p:cSld>
-  <p:clrMapOvr>
-    <a:masterClrMapping/>
-  </p:clrMapOvr>
-</p:sld>
-</file>
-
-<file path=ppt/slides/slide6.xml><?xml version="1.0" encoding="utf-8"?>
-<p:sld xmlns:a="http://schemas.openxmlformats.org/drawingml/2006/main" xmlns:r="http://schemas.openxmlformats.org/officeDocument/2006/relationships" xmlns:p="http://schemas.openxmlformats.org/presentationml/2006/main">
-  <p:cSld name="Slide 6">
-    <p:bg>
-      <p:bgPr>
-        <a:solidFill>
-          <a:srgbClr val="000000"/>
-        </a:solidFill>
-      </p:bgPr>
-    </p:bg>
-    <p:spTree>
-      <p:nvGrpSpPr>
-        <p:cNvPr id="1" name=""/>
-        <p:cNvGrpSpPr/>
-        <p:nvPr/>
-      </p:nvGrpSpPr>
-      <p:grpSpPr>
-        <a:xfrm>
-          <a:off x="0" y="0"/>
-          <a:ext cx="0" cy="0"/>
-          <a:chOff x="0" y="0"/>
-          <a:chExt cx="0" cy="0"/>
-        </a:xfrm>
-      </p:grpSpPr>
-      <p:sp>
-        <p:nvSpPr>
-          <p:cNvPr id="2" name="Text 0"/>
-          <p:cNvSpPr txBox="1"/>
-          <p:nvPr/>
-        </p:nvSpPr>
-        <p:spPr>
-          <a:xfrm>
-            <a:off x="548640" y="457200"/>
-            <a:ext cx="11064240" cy="5943600"/>
-          </a:xfrm>
-          <a:prstGeom prst="rect">
-            <a:avLst/>
-          </a:prstGeom>
-          <a:noFill/>
-          <a:ln/>
-        </p:spPr>
-        <p:txBody>
-          <a:bodyPr wrap="square" lIns="0" tIns="0" rIns="0" bIns="0" rtlCol="0" anchor="ctr"/>
-          <a:lstStyle/>
-          <a:p>
-            <a:pPr algn="ctr" indent="0" marL="0">
-              <a:buNone/>
-            </a:pPr>
-            <a:r>
-              <a:rPr lang="en-US" sz="4900" b="1" dirty="0">
-                <a:solidFill>
-                  <a:srgbClr val="FFFFFF"/>
-                </a:solidFill>
-                <a:latin typeface="Arial" pitchFamily="34" charset="0"/>
-                <a:ea typeface="Arial" pitchFamily="34" charset="-122"/>
-                <a:cs typeface="Arial" pitchFamily="34" charset="-120"/>
-              </a:rPr>
-              <a:t>Славте Царя небес, </a:t>
-            </a:r>
-            <a:endParaRPr lang="en-US" sz="4900" dirty="0"/>
-          </a:p>
-          <a:p>
-            <a:pPr algn="ctr" indent="0" marL="0">
-              <a:buNone/>
-            </a:pPr>
-            <a:r>
-              <a:rPr lang="en-US" sz="4900" b="1" dirty="0">
-                <a:solidFill>
-                  <a:srgbClr val="FFFFFF"/>
-                </a:solidFill>
-                <a:latin typeface="Arial" pitchFamily="34" charset="0"/>
-                <a:ea typeface="Arial" pitchFamily="34" charset="-122"/>
-                <a:cs typeface="Arial" pitchFamily="34" charset="-120"/>
-              </a:rPr>
-              <a:t>єдиного з Отцем!</a:t>
-            </a:r>
-            <a:endParaRPr lang="en-US" sz="4900" dirty="0"/>
-          </a:p>
-          <a:p>
-            <a:pPr algn="ctr" indent="0" marL="0">
-              <a:buNone/>
-            </a:pPr>
-            <a:r>
-              <a:rPr lang="en-US" sz="4900" b="1" dirty="0">
-                <a:solidFill>
-                  <a:srgbClr val="FFFFFF"/>
-                </a:solidFill>
-                <a:latin typeface="Arial" pitchFamily="34" charset="0"/>
-                <a:ea typeface="Arial" pitchFamily="34" charset="-122"/>
-                <a:cs typeface="Arial" pitchFamily="34" charset="-120"/>
-              </a:rPr>
-              <a:t>Святого Духа що в серцях </a:t>
-            </a:r>
-            <a:endParaRPr lang="en-US" sz="4900" dirty="0"/>
-          </a:p>
-          <a:p>
-            <a:pPr algn="ctr" indent="0" marL="0">
-              <a:buNone/>
-            </a:pPr>
-            <a:r>
-              <a:rPr lang="en-US" sz="4900" b="1" dirty="0">
-                <a:solidFill>
-                  <a:srgbClr val="FFFFFF"/>
-                </a:solidFill>
-                <a:latin typeface="Arial" pitchFamily="34" charset="0"/>
-                <a:ea typeface="Arial" pitchFamily="34" charset="-122"/>
-                <a:cs typeface="Arial" pitchFamily="34" charset="-120"/>
-              </a:rPr>
-              <a:t>відкуплених живе!</a:t>
-            </a:r>
-            <a:endParaRPr lang="en-US" sz="4900" dirty="0"/>
-          </a:p>
-        </p:txBody>
-      </p:sp>
-    </p:spTree>
-  </p:cSld>
-  <p:clrMapOvr>
-    <a:masterClrMapping/>
-  </p:clrMapOvr>
-</p:sld>
-</file>
-
-<file path=ppt/slides/slide7.xml><?xml version="1.0" encoding="utf-8"?>
-<p:sld xmlns:a="http://schemas.openxmlformats.org/drawingml/2006/main" xmlns:r="http://schemas.openxmlformats.org/officeDocument/2006/relationships" xmlns:p="http://schemas.openxmlformats.org/presentationml/2006/main">
-  <p:cSld name="Slide 7">
-    <p:bg>
-      <p:bgPr>
-        <a:solidFill>
-          <a:srgbClr val="000000"/>
-        </a:solidFill>
-      </p:bgPr>
-    </p:bg>
-    <p:spTree>
-      <p:nvGrpSpPr>
-        <p:cNvPr id="1" name=""/>
-        <p:cNvGrpSpPr/>
-        <p:nvPr/>
-      </p:nvGrpSpPr>
-      <p:grpSpPr>
-        <a:xfrm>
-          <a:off x="0" y="0"/>
-          <a:ext cx="0" cy="0"/>
-          <a:chOff x="0" y="0"/>
-          <a:chExt cx="0" cy="0"/>
-        </a:xfrm>
-      </p:grpSpPr>
-      <p:sp>
-        <p:nvSpPr>
-          <p:cNvPr id="2" name="Text 0"/>
-          <p:cNvSpPr txBox="1"/>
-          <p:nvPr/>
-        </p:nvSpPr>
-        <p:spPr>
-          <a:xfrm>
-            <a:off x="548640" y="457200"/>
-            <a:ext cx="11064240" cy="5943600"/>
-          </a:xfrm>
-          <a:prstGeom prst="rect">
-            <a:avLst/>
-          </a:prstGeom>
-          <a:noFill/>
-          <a:ln/>
-        </p:spPr>
-        <p:txBody>
-          <a:bodyPr wrap="square" lIns="0" tIns="0" rIns="0" bIns="0" rtlCol="0" anchor="ctr"/>
-          <a:lstStyle/>
-          <a:p>
-            <a:pPr algn="ctr" indent="0" marL="0">
-              <a:buNone/>
-            </a:pPr>
-            <a:r>
-              <a:rPr lang="en-US" sz="4900" b="1" dirty="0">
-                <a:solidFill>
-                  <a:srgbClr val="FFFFFF"/>
-                </a:solidFill>
-                <a:latin typeface="Arial" pitchFamily="34" charset="0"/>
-                <a:ea typeface="Arial" pitchFamily="34" charset="-122"/>
-                <a:cs typeface="Arial" pitchFamily="34" charset="-120"/>
-              </a:rPr>
-              <a:t>Народи племена </a:t>
-            </a:r>
-            <a:endParaRPr lang="en-US" sz="4900" dirty="0"/>
-          </a:p>
-          <a:p>
-            <a:pPr algn="ctr" indent="0" marL="0">
-              <a:buNone/>
-            </a:pPr>
-            <a:r>
-              <a:rPr lang="en-US" sz="4900" b="1" dirty="0">
-                <a:solidFill>
-                  <a:srgbClr val="FFFFFF"/>
-                </a:solidFill>
-                <a:latin typeface="Arial" pitchFamily="34" charset="0"/>
-                <a:ea typeface="Arial" pitchFamily="34" charset="-122"/>
-                <a:cs typeface="Arial" pitchFamily="34" charset="-120"/>
-              </a:rPr>
-              <a:t>звеличуйте Царя.</a:t>
-            </a:r>
-            <a:endParaRPr lang="en-US" sz="4900" dirty="0"/>
-          </a:p>
-          <a:p>
-            <a:pPr algn="ctr" indent="0" marL="0">
-              <a:buNone/>
-            </a:pPr>
-            <a:r>
-              <a:rPr lang="en-US" sz="4900" b="1" dirty="0">
-                <a:solidFill>
-                  <a:srgbClr val="FFFFFF"/>
-                </a:solidFill>
-                <a:latin typeface="Arial" pitchFamily="34" charset="0"/>
-                <a:ea typeface="Arial" pitchFamily="34" charset="-122"/>
-                <a:cs typeface="Arial" pitchFamily="34" charset="-120"/>
-              </a:rPr>
-              <a:t>Пошану й честь Йому складіть</a:t>
-            </a:r>
-            <a:endParaRPr lang="en-US" sz="4900" dirty="0"/>
-          </a:p>
-          <a:p>
-            <a:pPr algn="ctr" indent="0" marL="0">
-              <a:buNone/>
-            </a:pPr>
-            <a:r>
-              <a:rPr lang="en-US" sz="4900" b="1" dirty="0">
-                <a:solidFill>
-                  <a:srgbClr val="FFFFFF"/>
-                </a:solidFill>
-                <a:latin typeface="Arial" pitchFamily="34" charset="0"/>
-                <a:ea typeface="Arial" pitchFamily="34" charset="-122"/>
-                <a:cs typeface="Arial" pitchFamily="34" charset="-120"/>
-              </a:rPr>
-              <a:t>за всі Його діла.</a:t>
-            </a:r>
-            <a:endParaRPr lang="en-US" sz="4900" dirty="0"/>
-          </a:p>
-        </p:txBody>
-      </p:sp>
-    </p:spTree>
-  </p:cSld>
-  <p:clrMapOvr>
-    <a:masterClrMapping/>
-  </p:clrMapOvr>
-</p:sld>
-</file>
-
-<file path=ppt/slides/slide8.xml><?xml version="1.0" encoding="utf-8"?>
-<p:sld xmlns:a="http://schemas.openxmlformats.org/drawingml/2006/main" xmlns:r="http://schemas.openxmlformats.org/officeDocument/2006/relationships" xmlns:p="http://schemas.openxmlformats.org/presentationml/2006/main">
-  <p:cSld name="Slide 8">
-    <p:bg>
-      <p:bgPr>
-        <a:solidFill>
-          <a:srgbClr val="000000"/>
-        </a:solidFill>
-      </p:bgPr>
-    </p:bg>
-    <p:spTree>
-      <p:nvGrpSpPr>
-        <p:cNvPr id="1" name=""/>
-        <p:cNvGrpSpPr/>
-        <p:nvPr/>
-      </p:nvGrpSpPr>
-      <p:grpSpPr>
-        <a:xfrm>
-          <a:off x="0" y="0"/>
-          <a:ext cx="0" cy="0"/>
-          <a:chOff x="0" y="0"/>
-          <a:chExt cx="0" cy="0"/>
-        </a:xfrm>
-      </p:grpSpPr>
-      <p:sp>
-        <p:nvSpPr>
-          <p:cNvPr id="2" name="Text 0"/>
-          <p:cNvSpPr txBox="1"/>
-          <p:nvPr/>
-        </p:nvSpPr>
-        <p:spPr>
-          <a:xfrm>
-            <a:off x="548640" y="457200"/>
-            <a:ext cx="11064240" cy="5943600"/>
-          </a:xfrm>
-          <a:prstGeom prst="rect">
-            <a:avLst/>
-          </a:prstGeom>
-          <a:noFill/>
-          <a:ln/>
-        </p:spPr>
-        <p:txBody>
-          <a:bodyPr wrap="square" lIns="0" tIns="0" rIns="0" bIns="0" rtlCol="0" anchor="ctr"/>
-          <a:lstStyle/>
-          <a:p>
-            <a:pPr algn="ctr" indent="0" marL="0">
-              <a:buNone/>
-            </a:pPr>
-            <a:r>
-              <a:rPr lang="en-US" sz="4900" b="1" dirty="0">
-                <a:solidFill>
-                  <a:srgbClr val="FFFFFF"/>
-                </a:solidFill>
-                <a:latin typeface="Arial" pitchFamily="34" charset="0"/>
-                <a:ea typeface="Arial" pitchFamily="34" charset="-122"/>
-                <a:cs typeface="Arial" pitchFamily="34" charset="-120"/>
-              </a:rPr>
-              <a:t>Прославте всі Христа! </a:t>
-            </a:r>
-            <a:endParaRPr lang="en-US" sz="4900" dirty="0"/>
-          </a:p>
-          <a:p>
-            <a:pPr algn="ctr" indent="0" marL="0">
-              <a:buNone/>
-            </a:pPr>
-            <a:r>
-              <a:rPr lang="en-US" sz="4900" b="1" dirty="0">
-                <a:solidFill>
-                  <a:srgbClr val="FFFFFF"/>
-                </a:solidFill>
-                <a:latin typeface="Arial" pitchFamily="34" charset="0"/>
-                <a:ea typeface="Arial" pitchFamily="34" charset="-122"/>
-                <a:cs typeface="Arial" pitchFamily="34" charset="-120"/>
-              </a:rPr>
-              <a:t>Зійшов Він на престол.</a:t>
-            </a:r>
-            <a:endParaRPr lang="en-US" sz="4900" dirty="0"/>
-          </a:p>
-          <a:p>
-            <a:pPr algn="ctr" indent="0" marL="0">
-              <a:buNone/>
-            </a:pPr>
-            <a:r>
-              <a:rPr lang="en-US" sz="4900" b="1" dirty="0">
-                <a:solidFill>
-                  <a:srgbClr val="FFFFFF"/>
-                </a:solidFill>
-                <a:latin typeface="Arial" pitchFamily="34" charset="0"/>
-                <a:ea typeface="Arial" pitchFamily="34" charset="-122"/>
-                <a:cs typeface="Arial" pitchFamily="34" charset="-120"/>
-              </a:rPr>
-              <a:t>Співають Анголи в красі, </a:t>
-            </a:r>
-            <a:endParaRPr lang="en-US" sz="4900" dirty="0"/>
-          </a:p>
-          <a:p>
-            <a:pPr algn="ctr" indent="0" marL="0">
-              <a:buNone/>
-            </a:pPr>
-            <a:r>
-              <a:rPr lang="en-US" sz="4900" b="1" dirty="0">
-                <a:solidFill>
-                  <a:srgbClr val="FFFFFF"/>
-                </a:solidFill>
-                <a:latin typeface="Arial" pitchFamily="34" charset="0"/>
-                <a:ea typeface="Arial" pitchFamily="34" charset="-122"/>
-                <a:cs typeface="Arial" pitchFamily="34" charset="-120"/>
-              </a:rPr>
-              <a:t>звучить небесний хор.</a:t>
-            </a:r>
-            <a:endParaRPr lang="en-US" sz="4900" dirty="0"/>
-          </a:p>
-        </p:txBody>
-      </p:sp>
-    </p:spTree>
-  </p:cSld>
-  <p:clrMapOvr>
-    <a:masterClrMapping/>
-  </p:clrMapOvr>
-</p:sld>
-</file>
-
-<file path=ppt/slides/slide9.xml><?xml version="1.0" encoding="utf-8"?>
-<p:sld xmlns:a="http://schemas.openxmlformats.org/drawingml/2006/main" xmlns:r="http://schemas.openxmlformats.org/officeDocument/2006/relationships" xmlns:p="http://schemas.openxmlformats.org/presentationml/2006/main">
-  <p:cSld name="Slide 9">
-    <p:bg>
-      <p:bgPr>
-        <a:solidFill>
-          <a:srgbClr val="000000"/>
-        </a:solidFill>
-      </p:bgPr>
-    </p:bg>
-    <p:spTree>
-      <p:nvGrpSpPr>
-        <p:cNvPr id="1" name=""/>
-        <p:cNvGrpSpPr/>
-        <p:nvPr/>
-      </p:nvGrpSpPr>
-      <p:grpSpPr>
-        <a:xfrm>
-          <a:off x="0" y="0"/>
-          <a:ext cx="0" cy="0"/>
-          <a:chOff x="0" y="0"/>
-          <a:chExt cx="0" cy="0"/>
-        </a:xfrm>
-      </p:grpSpPr>
-      <p:sp>
-        <p:nvSpPr>
-          <p:cNvPr id="2" name="Text 0"/>
-          <p:cNvSpPr txBox="1"/>
-          <p:nvPr/>
-        </p:nvSpPr>
-        <p:spPr>
-          <a:xfrm>
-            <a:off x="548640" y="457200"/>
-            <a:ext cx="11064240" cy="5943600"/>
-          </a:xfrm>
-          <a:prstGeom prst="rect">
-            <a:avLst/>
-          </a:prstGeom>
-          <a:noFill/>
-          <a:ln/>
-        </p:spPr>
-        <p:txBody>
-          <a:bodyPr wrap="square" lIns="0" tIns="0" rIns="0" bIns="0" rtlCol="0" anchor="ctr"/>
-          <a:lstStyle/>
-          <a:p>
-            <a:pPr algn="ctr" indent="0" marL="0">
-              <a:buNone/>
-            </a:pPr>
-            <a:r>
-              <a:rPr lang="en-US" sz="4900" b="1" dirty="0">
-                <a:solidFill>
-                  <a:srgbClr val="FFFFFF"/>
-                </a:solidFill>
-                <a:latin typeface="Arial" pitchFamily="34" charset="0"/>
-                <a:ea typeface="Arial" pitchFamily="34" charset="-122"/>
-                <a:cs typeface="Arial" pitchFamily="34" charset="-120"/>
-              </a:rPr>
-              <a:t>Співай душа, радій, </a:t>
-            </a:r>
-            <a:endParaRPr lang="en-US" sz="4900" dirty="0"/>
-          </a:p>
-          <a:p>
-            <a:pPr algn="ctr" indent="0" marL="0">
-              <a:buNone/>
-            </a:pPr>
-            <a:r>
-              <a:rPr lang="en-US" sz="4900" b="1" dirty="0">
-                <a:solidFill>
-                  <a:srgbClr val="FFFFFF"/>
-                </a:solidFill>
-                <a:latin typeface="Arial" pitchFamily="34" charset="0"/>
-                <a:ea typeface="Arial" pitchFamily="34" charset="-122"/>
-                <a:cs typeface="Arial" pitchFamily="34" charset="-120"/>
-              </a:rPr>
-              <a:t>Христос Спаситель твій,</a:t>
-            </a:r>
-            <a:endParaRPr lang="en-US" sz="4900" dirty="0"/>
-          </a:p>
-          <a:p>
-            <a:pPr algn="ctr" indent="0" marL="0">
-              <a:buNone/>
-            </a:pPr>
-            <a:r>
-              <a:rPr lang="en-US" sz="4900" b="1" dirty="0">
-                <a:solidFill>
-                  <a:srgbClr val="FFFFFF"/>
-                </a:solidFill>
-                <a:latin typeface="Arial" pitchFamily="34" charset="0"/>
-                <a:ea typeface="Arial" pitchFamily="34" charset="-122"/>
-                <a:cs typeface="Arial" pitchFamily="34" charset="-120"/>
-              </a:rPr>
-              <a:t>Він Відкупитель всеблагий, </a:t>
-            </a:r>
-            <a:endParaRPr lang="en-US" sz="4900" dirty="0"/>
-          </a:p>
-          <a:p>
-            <a:pPr algn="ctr" indent="0" marL="0">
-              <a:buNone/>
-            </a:pPr>
-            <a:r>
-              <a:rPr lang="en-US" sz="4900" b="1" dirty="0">
-                <a:solidFill>
-                  <a:srgbClr val="FFFFFF"/>
-                </a:solidFill>
-                <a:latin typeface="Arial" pitchFamily="34" charset="0"/>
-                <a:ea typeface="Arial" pitchFamily="34" charset="-122"/>
-                <a:cs typeface="Arial" pitchFamily="34" charset="-120"/>
-              </a:rPr>
-              <a:t>Він Цар твій назавжди.</a:t>
-            </a:r>
-            <a:endParaRPr lang="en-US" sz="4900" dirty="0"/>
-          </a:p>
-        </p:txBody>
-      </p:sp>
     </p:spTree>
   </p:cSld>
   <p:clrMapOvr>

</xml_diff>